<commit_message>
Anti-Bullying Week: registered supporter line.
</commit_message>
<xml_diff>
--- a/assemblies-and-events/anti-bullying-week/downloads/Anti_Bullying_Week.pptx
+++ b/assemblies-and-events/anti-bullying-week/downloads/Anti_Bullying_Week.pptx
@@ -4421,7 +4421,7 @@
                 </a:solidFill>
                 <a:latin typeface="Libre Caslon Display"/>
               </a:rPr>
-              <a:t>Odd Sock Day</a:t>
+              <a:t>Odd Socks Day</a:t>
             </a:r>
           </a:p>
         </p:txBody>
@@ -5517,7 +5517,7 @@
                 </a:solidFill>
                 <a:latin typeface="Libre Caslon Display"/>
               </a:rPr>
-              <a:t>Odd Sock Day</a:t>
+              <a:t>Odd Socks Day</a:t>
             </a:r>
           </a:p>
         </p:txBody>

</xml_diff>

<commit_message>
Switch everything to Georgia and Calibri, remove slide pills, new photos
</commit_message>
<xml_diff>
--- a/assemblies-and-events/anti-bullying-week/downloads/Anti_Bullying_Week.pptx
+++ b/assemblies-and-events/anti-bullying-week/downloads/Anti_Bullying_Week.pptx
@@ -3196,11 +3196,11 @@
               </a:spcAft>
             </a:pPr>
             <a:r>
-              <a:rPr sz="4800" b="1" i="0">
+              <a:rPr sz="4800" b="0" i="0">
                 <a:solidFill>
                   <a:srgbClr val="5B4F73"/>
                 </a:solidFill>
-                <a:latin typeface="Libre Caslon Display"/>
+                <a:latin typeface="Georgia"/>
               </a:rPr>
               <a:t>Anti-Bullying Week</a:t>
             </a:r>
@@ -3286,7 +3286,7 @@
                 <a:solidFill>
                   <a:srgbClr val="756F80"/>
                 </a:solidFill>
-                <a:latin typeface="Karla"/>
+                <a:latin typeface="Calibri"/>
               </a:rPr>
               <a:t>Five Themed Days</a:t>
             </a:r>
@@ -3328,7 +3328,7 @@
                 <a:solidFill>
                   <a:srgbClr val="A9A3B2"/>
                 </a:solidFill>
-                <a:latin typeface="Karla"/>
+                <a:latin typeface="Calibri"/>
               </a:rPr>
               <a:t>[ DATES ]</a:t>
             </a:r>
@@ -3394,7 +3394,7 @@
                 <a:solidFill>
                   <a:srgbClr val="A9A3B2"/>
                 </a:solidFill>
-                <a:latin typeface="Karla"/>
+                <a:latin typeface="Calibri"/>
               </a:rPr>
               <a:t>The Pastoral Guide</a:t>
             </a:r>
@@ -3436,7 +3436,7 @@
                 <a:solidFill>
                   <a:srgbClr val="A9A3B2"/>
                 </a:solidFill>
-                <a:latin typeface="Karla"/>
+                <a:latin typeface="Calibri"/>
               </a:rPr>
               <a:t>1 / 10</a:t>
             </a:r>
@@ -3560,11 +3560,11 @@
               </a:spcAft>
             </a:pPr>
             <a:r>
-              <a:rPr sz="3200" b="1" i="0">
+              <a:rPr sz="3200" b="0" i="0">
                 <a:solidFill>
                   <a:srgbClr val="5B4F73"/>
                 </a:solidFill>
-                <a:latin typeface="Libre Caslon Display"/>
+                <a:latin typeface="Georgia"/>
               </a:rPr>
               <a:t>One week will not fix it.</a:t>
             </a:r>
@@ -3606,7 +3606,7 @@
                 <a:solidFill>
                   <a:srgbClr val="756F80"/>
                 </a:solidFill>
-                <a:latin typeface="Karla"/>
+                <a:latin typeface="Calibri"/>
               </a:rPr>
               <a:t>Five days of noticing who is on their own, though, is a start. That part does not end on Friday.</a:t>
             </a:r>
@@ -3648,7 +3648,7 @@
                 <a:solidFill>
                   <a:srgbClr val="A9A3B2"/>
                 </a:solidFill>
-                <a:latin typeface="Karla"/>
+                <a:latin typeface="Calibri"/>
               </a:rPr>
               <a:t>Anti-Bullying Week  ·  Five Themed Days</a:t>
             </a:r>
@@ -3714,7 +3714,7 @@
                 <a:solidFill>
                   <a:srgbClr val="A9A3B2"/>
                 </a:solidFill>
-                <a:latin typeface="Karla"/>
+                <a:latin typeface="Calibri"/>
               </a:rPr>
               <a:t>The Pastoral Guide</a:t>
             </a:r>
@@ -3756,7 +3756,7 @@
                 <a:solidFill>
                   <a:srgbClr val="A9A3B2"/>
                 </a:solidFill>
-                <a:latin typeface="Karla"/>
+                <a:latin typeface="Calibri"/>
               </a:rPr>
               <a:t>10 / 10</a:t>
             </a:r>
@@ -3856,11 +3856,11 @@
               </a:spcAft>
             </a:pPr>
             <a:r>
-              <a:rPr sz="2800" b="1" i="0">
+              <a:rPr sz="2800" b="0" i="0">
                 <a:solidFill>
                   <a:srgbClr val="FFFDF7"/>
                 </a:solidFill>
-                <a:latin typeface="Libre Caslon Display"/>
+                <a:latin typeface="Georgia"/>
               </a:rPr>
               <a:t>Most of it is not a fight.</a:t>
             </a:r>
@@ -3875,11 +3875,11 @@
               </a:spcAft>
             </a:pPr>
             <a:r>
-              <a:rPr sz="2800" b="1" i="0">
+              <a:rPr sz="2800" b="0" i="0">
                 <a:solidFill>
                   <a:srgbClr val="FFFDF7"/>
                 </a:solidFill>
-                <a:latin typeface="Libre Caslon Display"/>
+                <a:latin typeface="Georgia"/>
               </a:rPr>
               <a:t>It is being left out, talked about, or made the joke.</a:t>
             </a:r>
@@ -3965,7 +3965,7 @@
                 <a:solidFill>
                   <a:srgbClr val="D3CCDF"/>
                 </a:solidFill>
-                <a:latin typeface="Karla"/>
+                <a:latin typeface="Calibri"/>
               </a:rPr>
               <a:t>Which is what makes it easy to miss, and easy to join in with without meaning to.</a:t>
             </a:r>
@@ -4031,7 +4031,7 @@
                 <a:solidFill>
                   <a:srgbClr val="D3CCDF"/>
                 </a:solidFill>
-                <a:latin typeface="Karla"/>
+                <a:latin typeface="Calibri"/>
               </a:rPr>
               <a:t>The Pastoral Guide</a:t>
             </a:r>
@@ -4073,7 +4073,7 @@
                 <a:solidFill>
                   <a:srgbClr val="D3CCDF"/>
                 </a:solidFill>
-                <a:latin typeface="Karla"/>
+                <a:latin typeface="Calibri"/>
               </a:rPr>
               <a:t>2 / 10</a:t>
             </a:r>
@@ -4177,7 +4177,7 @@
                 <a:solidFill>
                   <a:srgbClr val="5B4F73"/>
                 </a:solidFill>
-                <a:latin typeface="Karla"/>
+                <a:latin typeface="Calibri"/>
               </a:rPr>
               <a:t>THE WEEK AHEAD</a:t>
             </a:r>
@@ -4215,11 +4215,11 @@
               </a:spcAft>
             </a:pPr>
             <a:r>
-              <a:rPr sz="3000" b="1" i="0">
+              <a:rPr sz="3000" b="0" i="0">
                 <a:solidFill>
                   <a:srgbClr val="44404C"/>
                 </a:solidFill>
-                <a:latin typeface="Libre Caslon Display"/>
+                <a:latin typeface="Georgia"/>
               </a:rPr>
               <a:t>Five days, five things</a:t>
             </a:r>
@@ -4309,7 +4309,7 @@
                 <a:solidFill>
                   <a:srgbClr val="A094B5"/>
                 </a:solidFill>
-                <a:latin typeface="Karla"/>
+                <a:latin typeface="Calibri"/>
               </a:rPr>
               <a:t>MON</a:t>
             </a:r>
@@ -4415,11 +4415,11 @@
               </a:spcAft>
             </a:pPr>
             <a:r>
-              <a:rPr sz="1400" b="1" i="0">
+              <a:rPr sz="1400" b="0" i="0">
                 <a:solidFill>
                   <a:srgbClr val="5B4F73"/>
                 </a:solidFill>
-                <a:latin typeface="Libre Caslon Display"/>
+                <a:latin typeface="Georgia"/>
               </a:rPr>
               <a:t>Odd Socks Day</a:t>
             </a:r>
@@ -4509,7 +4509,7 @@
                 <a:solidFill>
                   <a:srgbClr val="A094B5"/>
                 </a:solidFill>
-                <a:latin typeface="Karla"/>
+                <a:latin typeface="Calibri"/>
               </a:rPr>
               <a:t>TUE</a:t>
             </a:r>
@@ -4615,11 +4615,11 @@
               </a:spcAft>
             </a:pPr>
             <a:r>
-              <a:rPr sz="1400" b="1" i="0">
+              <a:rPr sz="1400" b="0" i="0">
                 <a:solidFill>
                   <a:srgbClr val="5B4F73"/>
                 </a:solidFill>
-                <a:latin typeface="Libre Caslon Display"/>
+                <a:latin typeface="Georgia"/>
               </a:rPr>
               <a:t>Mix-It-Up Lunch</a:t>
             </a:r>
@@ -4709,7 +4709,7 @@
                 <a:solidFill>
                   <a:srgbClr val="A094B5"/>
                 </a:solidFill>
-                <a:latin typeface="Karla"/>
+                <a:latin typeface="Calibri"/>
               </a:rPr>
               <a:t>WED</a:t>
             </a:r>
@@ -4815,11 +4815,11 @@
               </a:spcAft>
             </a:pPr>
             <a:r>
-              <a:rPr sz="1400" b="1" i="0">
+              <a:rPr sz="1400" b="0" i="0">
                 <a:solidFill>
                   <a:srgbClr val="5B4F73"/>
                 </a:solidFill>
-                <a:latin typeface="Libre Caslon Display"/>
+                <a:latin typeface="Georgia"/>
               </a:rPr>
               <a:t>Friendship Bracelets</a:t>
             </a:r>
@@ -4909,7 +4909,7 @@
                 <a:solidFill>
                   <a:srgbClr val="A094B5"/>
                 </a:solidFill>
-                <a:latin typeface="Karla"/>
+                <a:latin typeface="Calibri"/>
               </a:rPr>
               <a:t>THU</a:t>
             </a:r>
@@ -5015,11 +5015,11 @@
               </a:spcAft>
             </a:pPr>
             <a:r>
-              <a:rPr sz="1400" b="1" i="0">
+              <a:rPr sz="1400" b="0" i="0">
                 <a:solidFill>
                   <a:srgbClr val="5B4F73"/>
                 </a:solidFill>
-                <a:latin typeface="Libre Caslon Display"/>
+                <a:latin typeface="Georgia"/>
               </a:rPr>
               <a:t>The Group Chat</a:t>
             </a:r>
@@ -5109,7 +5109,7 @@
                 <a:solidFill>
                   <a:srgbClr val="A094B5"/>
                 </a:solidFill>
-                <a:latin typeface="Karla"/>
+                <a:latin typeface="Calibri"/>
               </a:rPr>
               <a:t>FRI</a:t>
             </a:r>
@@ -5215,11 +5215,11 @@
               </a:spcAft>
             </a:pPr>
             <a:r>
-              <a:rPr sz="1400" b="1" i="0">
+              <a:rPr sz="1400" b="0" i="0">
                 <a:solidFill>
                   <a:srgbClr val="5B4F73"/>
                 </a:solidFill>
-                <a:latin typeface="Libre Caslon Display"/>
+                <a:latin typeface="Georgia"/>
               </a:rPr>
               <a:t>The Positivity Tree</a:t>
             </a:r>
@@ -5261,7 +5261,7 @@
                 <a:solidFill>
                   <a:srgbClr val="756F80"/>
                 </a:solidFill>
-                <a:latin typeface="Karla"/>
+                <a:latin typeface="Calibri"/>
               </a:rPr>
               <a:t>Each one takes about five minutes of your day, and none of them will get you into trouble.</a:t>
             </a:r>
@@ -5327,7 +5327,7 @@
                 <a:solidFill>
                   <a:srgbClr val="A9A3B2"/>
                 </a:solidFill>
-                <a:latin typeface="Karla"/>
+                <a:latin typeface="Calibri"/>
               </a:rPr>
               <a:t>The Pastoral Guide</a:t>
             </a:r>
@@ -5369,7 +5369,7 @@
                 <a:solidFill>
                   <a:srgbClr val="A9A3B2"/>
                 </a:solidFill>
-                <a:latin typeface="Karla"/>
+                <a:latin typeface="Calibri"/>
               </a:rPr>
               <a:t>3 / 10</a:t>
             </a:r>
@@ -5473,7 +5473,7 @@
                 <a:solidFill>
                   <a:srgbClr val="5B4F73"/>
                 </a:solidFill>
-                <a:latin typeface="Karla"/>
+                <a:latin typeface="Calibri"/>
               </a:rPr>
               <a:t>DAY ONE  ·  MONDAY</a:t>
             </a:r>
@@ -5511,11 +5511,11 @@
               </a:spcAft>
             </a:pPr>
             <a:r>
-              <a:rPr sz="3200" b="1" i="0">
+              <a:rPr sz="3200" b="0" i="0">
                 <a:solidFill>
                   <a:srgbClr val="44404C"/>
                 </a:solidFill>
-                <a:latin typeface="Libre Caslon Display"/>
+                <a:latin typeface="Georgia"/>
               </a:rPr>
               <a:t>Odd Socks Day</a:t>
             </a:r>
@@ -5605,7 +5605,7 @@
                 <a:solidFill>
                   <a:srgbClr val="5B4F73"/>
                 </a:solidFill>
-                <a:latin typeface="Karla"/>
+                <a:latin typeface="Calibri"/>
               </a:rPr>
               <a:t>What is happening</a:t>
             </a:r>
@@ -5647,7 +5647,7 @@
                 <a:solidFill>
                   <a:srgbClr val="44404C"/>
                 </a:solidFill>
-                <a:latin typeface="Karla"/>
+                <a:latin typeface="Calibri"/>
               </a:rPr>
               <a:t>Wear odd socks with your uniform, all day. That is all there is to it. It takes two seconds to look different from everyone else, and nobody should get a hard time for it.</a:t>
             </a:r>
@@ -5805,7 +5805,7 @@
                 <a:solidFill>
                   <a:srgbClr val="5B4F73"/>
                 </a:solidFill>
-                <a:latin typeface="Karla"/>
+                <a:latin typeface="Calibri"/>
               </a:rPr>
               <a:t>All day</a:t>
             </a:r>
@@ -5824,7 +5824,7 @@
                 <a:solidFill>
                   <a:srgbClr val="5B4F73"/>
                 </a:solidFill>
-                <a:latin typeface="Karla"/>
+                <a:latin typeface="Calibri"/>
               </a:rPr>
               <a:t>Nothing to bring</a:t>
             </a:r>
@@ -5866,7 +5866,7 @@
                 <a:solidFill>
                   <a:srgbClr val="756F80"/>
                 </a:solidFill>
-                <a:latin typeface="Karla"/>
+                <a:latin typeface="Calibri"/>
               </a:rPr>
               <a:t>Odd socks only. The rest of the uniform stays exactly as normal.</a:t>
             </a:r>
@@ -5932,7 +5932,7 @@
                 <a:solidFill>
                   <a:srgbClr val="A9A3B2"/>
                 </a:solidFill>
-                <a:latin typeface="Karla"/>
+                <a:latin typeface="Calibri"/>
               </a:rPr>
               <a:t>The Pastoral Guide</a:t>
             </a:r>
@@ -5974,7 +5974,7 @@
                 <a:solidFill>
                   <a:srgbClr val="A9A3B2"/>
                 </a:solidFill>
-                <a:latin typeface="Karla"/>
+                <a:latin typeface="Calibri"/>
               </a:rPr>
               <a:t>4 / 10</a:t>
             </a:r>
@@ -6078,7 +6078,7 @@
                 <a:solidFill>
                   <a:srgbClr val="5B4F73"/>
                 </a:solidFill>
-                <a:latin typeface="Karla"/>
+                <a:latin typeface="Calibri"/>
               </a:rPr>
               <a:t>DAY TWO  ·  TUESDAY</a:t>
             </a:r>
@@ -6116,11 +6116,11 @@
               </a:spcAft>
             </a:pPr>
             <a:r>
-              <a:rPr sz="3200" b="1" i="0">
+              <a:rPr sz="3200" b="0" i="0">
                 <a:solidFill>
                   <a:srgbClr val="44404C"/>
                 </a:solidFill>
-                <a:latin typeface="Libre Caslon Display"/>
+                <a:latin typeface="Georgia"/>
               </a:rPr>
               <a:t>Mix-It-Up Lunch</a:t>
             </a:r>
@@ -6210,7 +6210,7 @@
                 <a:solidFill>
                   <a:srgbClr val="5B4F73"/>
                 </a:solidFill>
-                <a:latin typeface="Karla"/>
+                <a:latin typeface="Calibri"/>
               </a:rPr>
               <a:t>What is happening</a:t>
             </a:r>
@@ -6252,7 +6252,7 @@
                 <a:solidFill>
                   <a:srgbClr val="44404C"/>
                 </a:solidFill>
-                <a:latin typeface="Karla"/>
+                <a:latin typeface="Calibri"/>
               </a:rPr>
               <a:t>Every table in the hall has a topic card on it. Sit at a table with people you do not usually sit with, and talk about whatever the card says.</a:t>
             </a:r>
@@ -6410,7 +6410,7 @@
                 <a:solidFill>
                   <a:srgbClr val="5B4F73"/>
                 </a:solidFill>
-                <a:latin typeface="Karla"/>
+                <a:latin typeface="Calibri"/>
               </a:rPr>
               <a:t>[ THE HALL ]</a:t>
             </a:r>
@@ -6429,7 +6429,7 @@
                 <a:solidFill>
                   <a:srgbClr val="5B4F73"/>
                 </a:solidFill>
-                <a:latin typeface="Karla"/>
+                <a:latin typeface="Calibri"/>
               </a:rPr>
               <a:t>All of lunch</a:t>
             </a:r>
@@ -6471,7 +6471,7 @@
                 <a:solidFill>
                   <a:srgbClr val="756F80"/>
                 </a:solidFill>
-                <a:latin typeface="Karla"/>
+                <a:latin typeface="Calibri"/>
               </a:rPr>
               <a:t>If you would rather not, that is fine. Nobody is going to make you move.</a:t>
             </a:r>
@@ -6537,7 +6537,7 @@
                 <a:solidFill>
                   <a:srgbClr val="A9A3B2"/>
                 </a:solidFill>
-                <a:latin typeface="Karla"/>
+                <a:latin typeface="Calibri"/>
               </a:rPr>
               <a:t>The Pastoral Guide</a:t>
             </a:r>
@@ -6579,7 +6579,7 @@
                 <a:solidFill>
                   <a:srgbClr val="A9A3B2"/>
                 </a:solidFill>
-                <a:latin typeface="Karla"/>
+                <a:latin typeface="Calibri"/>
               </a:rPr>
               <a:t>5 / 10</a:t>
             </a:r>
@@ -6683,7 +6683,7 @@
                 <a:solidFill>
                   <a:srgbClr val="5B4F73"/>
                 </a:solidFill>
-                <a:latin typeface="Karla"/>
+                <a:latin typeface="Calibri"/>
               </a:rPr>
               <a:t>DAY THREE  ·  WEDNESDAY</a:t>
             </a:r>
@@ -6721,11 +6721,11 @@
               </a:spcAft>
             </a:pPr>
             <a:r>
-              <a:rPr sz="3200" b="1" i="0">
+              <a:rPr sz="3200" b="0" i="0">
                 <a:solidFill>
                   <a:srgbClr val="44404C"/>
                 </a:solidFill>
-                <a:latin typeface="Libre Caslon Display"/>
+                <a:latin typeface="Georgia"/>
               </a:rPr>
               <a:t>Friendship Bracelets</a:t>
             </a:r>
@@ -6815,7 +6815,7 @@
                 <a:solidFill>
                   <a:srgbClr val="5B4F73"/>
                 </a:solidFill>
-                <a:latin typeface="Karla"/>
+                <a:latin typeface="Calibri"/>
               </a:rPr>
               <a:t>What is happening</a:t>
             </a:r>
@@ -6857,7 +6857,7 @@
                 <a:solidFill>
                   <a:srgbClr val="44404C"/>
                 </a:solidFill>
-                <a:latin typeface="Karla"/>
+                <a:latin typeface="Calibri"/>
               </a:rPr>
               <a:t>Come and make a bracelet at lunch. You make two: one to keep, and one to give to somebody who would not be expecting it.</a:t>
             </a:r>
@@ -7015,7 +7015,7 @@
                 <a:solidFill>
                   <a:srgbClr val="5B4F73"/>
                 </a:solidFill>
-                <a:latin typeface="Karla"/>
+                <a:latin typeface="Calibri"/>
               </a:rPr>
               <a:t>[ ROOM ]</a:t>
             </a:r>
@@ -7034,7 +7034,7 @@
                 <a:solidFill>
                   <a:srgbClr val="5B4F73"/>
                 </a:solidFill>
-                <a:latin typeface="Karla"/>
+                <a:latin typeface="Calibri"/>
               </a:rPr>
               <a:t>Lunchtime</a:t>
             </a:r>
@@ -7076,7 +7076,7 @@
                 <a:solidFill>
                   <a:srgbClr val="756F80"/>
                 </a:solidFill>
-                <a:latin typeface="Karla"/>
+                <a:latin typeface="Calibri"/>
               </a:rPr>
               <a:t>Thread and beads are provided. First come, first served.</a:t>
             </a:r>
@@ -7142,7 +7142,7 @@
                 <a:solidFill>
                   <a:srgbClr val="A9A3B2"/>
                 </a:solidFill>
-                <a:latin typeface="Karla"/>
+                <a:latin typeface="Calibri"/>
               </a:rPr>
               <a:t>The Pastoral Guide</a:t>
             </a:r>
@@ -7184,7 +7184,7 @@
                 <a:solidFill>
                   <a:srgbClr val="A9A3B2"/>
                 </a:solidFill>
-                <a:latin typeface="Karla"/>
+                <a:latin typeface="Calibri"/>
               </a:rPr>
               <a:t>6 / 10</a:t>
             </a:r>
@@ -7288,7 +7288,7 @@
                 <a:solidFill>
                   <a:srgbClr val="5B4F73"/>
                 </a:solidFill>
-                <a:latin typeface="Karla"/>
+                <a:latin typeface="Calibri"/>
               </a:rPr>
               <a:t>DAY FOUR  ·  THURSDAY</a:t>
             </a:r>
@@ -7326,11 +7326,11 @@
               </a:spcAft>
             </a:pPr>
             <a:r>
-              <a:rPr sz="3200" b="1" i="0">
+              <a:rPr sz="3200" b="0" i="0">
                 <a:solidFill>
                   <a:srgbClr val="44404C"/>
                 </a:solidFill>
-                <a:latin typeface="Libre Caslon Display"/>
+                <a:latin typeface="Georgia"/>
               </a:rPr>
               <a:t>The Group Chat</a:t>
             </a:r>
@@ -7420,7 +7420,7 @@
                 <a:solidFill>
                   <a:srgbClr val="5B4F73"/>
                 </a:solidFill>
-                <a:latin typeface="Karla"/>
+                <a:latin typeface="Calibri"/>
               </a:rPr>
               <a:t>What is happening</a:t>
             </a:r>
@@ -7462,7 +7462,7 @@
                 <a:solidFill>
                   <a:srgbClr val="44404C"/>
                 </a:solidFill>
-                <a:latin typeface="Karla"/>
+                <a:latin typeface="Calibri"/>
               </a:rPr>
               <a:t>A group chat goes up on the wall. Read it, then put a sticky note where you think it went wrong, and what you would have said instead.</a:t>
             </a:r>
@@ -7620,7 +7620,7 @@
                 <a:solidFill>
                   <a:srgbClr val="5B4F73"/>
                 </a:solidFill>
-                <a:latin typeface="Karla"/>
+                <a:latin typeface="Calibri"/>
               </a:rPr>
               <a:t>[ PLACE ]</a:t>
             </a:r>
@@ -7639,7 +7639,7 @@
                 <a:solidFill>
                   <a:srgbClr val="5B4F73"/>
                 </a:solidFill>
-                <a:latin typeface="Karla"/>
+                <a:latin typeface="Calibri"/>
               </a:rPr>
               <a:t>All day</a:t>
             </a:r>
@@ -7681,7 +7681,7 @@
                 <a:solidFill>
                   <a:srgbClr val="756F80"/>
                 </a:solidFill>
-                <a:latin typeface="Karla"/>
+                <a:latin typeface="Calibri"/>
               </a:rPr>
               <a:t>It is not a real chat, and it is not about anyone here.</a:t>
             </a:r>
@@ -7747,7 +7747,7 @@
                 <a:solidFill>
                   <a:srgbClr val="A9A3B2"/>
                 </a:solidFill>
-                <a:latin typeface="Karla"/>
+                <a:latin typeface="Calibri"/>
               </a:rPr>
               <a:t>The Pastoral Guide</a:t>
             </a:r>
@@ -7789,7 +7789,7 @@
                 <a:solidFill>
                   <a:srgbClr val="A9A3B2"/>
                 </a:solidFill>
-                <a:latin typeface="Karla"/>
+                <a:latin typeface="Calibri"/>
               </a:rPr>
               <a:t>7 / 10</a:t>
             </a:r>
@@ -7893,7 +7893,7 @@
                 <a:solidFill>
                   <a:srgbClr val="5B4F73"/>
                 </a:solidFill>
-                <a:latin typeface="Karla"/>
+                <a:latin typeface="Calibri"/>
               </a:rPr>
               <a:t>DAY FIVE  ·  FRIDAY</a:t>
             </a:r>
@@ -7931,11 +7931,11 @@
               </a:spcAft>
             </a:pPr>
             <a:r>
-              <a:rPr sz="3200" b="1" i="0">
+              <a:rPr sz="3200" b="0" i="0">
                 <a:solidFill>
                   <a:srgbClr val="44404C"/>
                 </a:solidFill>
-                <a:latin typeface="Libre Caslon Display"/>
+                <a:latin typeface="Georgia"/>
               </a:rPr>
               <a:t>The Positivity Tree</a:t>
             </a:r>
@@ -8025,7 +8025,7 @@
                 <a:solidFill>
                   <a:srgbClr val="5B4F73"/>
                 </a:solidFill>
-                <a:latin typeface="Karla"/>
+                <a:latin typeface="Calibri"/>
               </a:rPr>
               <a:t>What is happening</a:t>
             </a:r>
@@ -8067,7 +8067,7 @@
                 <a:solidFill>
                   <a:srgbClr val="44404C"/>
                 </a:solidFill>
-                <a:latin typeface="Karla"/>
+                <a:latin typeface="Calibri"/>
               </a:rPr>
               <a:t>Write something good about somebody in this school on a leaf, and hang it up. Not your best friend. Somebody who would not expect it from you.</a:t>
             </a:r>
@@ -8225,7 +8225,7 @@
                 <a:solidFill>
                   <a:srgbClr val="5B4F73"/>
                 </a:solidFill>
-                <a:latin typeface="Karla"/>
+                <a:latin typeface="Calibri"/>
               </a:rPr>
               <a:t>[ THE TREE ]</a:t>
             </a:r>
@@ -8244,7 +8244,7 @@
                 <a:solidFill>
                   <a:srgbClr val="5B4F73"/>
                 </a:solidFill>
-                <a:latin typeface="Karla"/>
+                <a:latin typeface="Calibri"/>
               </a:rPr>
               <a:t>Lunchtime</a:t>
             </a:r>
@@ -8286,7 +8286,7 @@
                 <a:solidFill>
                   <a:srgbClr val="756F80"/>
                 </a:solidFill>
-                <a:latin typeface="Karla"/>
+                <a:latin typeface="Calibri"/>
               </a:rPr>
               <a:t>You do not sign it. By the end of lunch the tree should be covered.</a:t>
             </a:r>
@@ -8352,7 +8352,7 @@
                 <a:solidFill>
                   <a:srgbClr val="A9A3B2"/>
                 </a:solidFill>
-                <a:latin typeface="Karla"/>
+                <a:latin typeface="Calibri"/>
               </a:rPr>
               <a:t>The Pastoral Guide</a:t>
             </a:r>
@@ -8394,7 +8394,7 @@
                 <a:solidFill>
                   <a:srgbClr val="A9A3B2"/>
                 </a:solidFill>
-                <a:latin typeface="Karla"/>
+                <a:latin typeface="Calibri"/>
               </a:rPr>
               <a:t>8 / 10</a:t>
             </a:r>
@@ -8498,7 +8498,7 @@
                 <a:solidFill>
                   <a:srgbClr val="5B4F73"/>
                 </a:solidFill>
-                <a:latin typeface="Karla"/>
+                <a:latin typeface="Calibri"/>
               </a:rPr>
               <a:t>ONE MORE THING</a:t>
             </a:r>
@@ -8536,11 +8536,11 @@
               </a:spcAft>
             </a:pPr>
             <a:r>
-              <a:rPr sz="3000" b="1" i="0">
+              <a:rPr sz="3000" b="0" i="0">
                 <a:solidFill>
                   <a:srgbClr val="44404C"/>
                 </a:solidFill>
-                <a:latin typeface="Libre Caslon Display"/>
+                <a:latin typeface="Georgia"/>
               </a:rPr>
               <a:t>If any of this is happening to you</a:t>
             </a:r>
@@ -8582,7 +8582,7 @@
                 <a:solidFill>
                   <a:srgbClr val="756F80"/>
                 </a:solidFill>
-                <a:latin typeface="Karla"/>
+                <a:latin typeface="Calibri"/>
               </a:rPr>
               <a:t>Or you have watched it happen to someone else and said nothing. That counts too.</a:t>
             </a:r>
@@ -8736,11 +8736,11 @@
               </a:spcAft>
             </a:pPr>
             <a:r>
-              <a:rPr sz="1350" b="1" i="0">
+              <a:rPr sz="1350" b="0" i="0">
                 <a:solidFill>
                   <a:srgbClr val="5B4F73"/>
                 </a:solidFill>
-                <a:latin typeface="Libre Caslon Display"/>
+                <a:latin typeface="Georgia"/>
               </a:rPr>
               <a:t>Your form tutor</a:t>
             </a:r>
@@ -8782,7 +8782,7 @@
                 <a:solidFill>
                   <a:srgbClr val="756F80"/>
                 </a:solidFill>
-                <a:latin typeface="Karla"/>
+                <a:latin typeface="Calibri"/>
               </a:rPr>
               <a:t>Any morning, before anything else starts.</a:t>
             </a:r>
@@ -8936,11 +8936,11 @@
               </a:spcAft>
             </a:pPr>
             <a:r>
-              <a:rPr sz="1350" b="1" i="0">
+              <a:rPr sz="1350" b="0" i="0">
                 <a:solidFill>
                   <a:srgbClr val="5B4F73"/>
                 </a:solidFill>
-                <a:latin typeface="Libre Caslon Display"/>
+                <a:latin typeface="Georgia"/>
               </a:rPr>
               <a:t>[ NAMED STAFF ]</a:t>
             </a:r>
@@ -8982,7 +8982,7 @@
                 <a:solidFill>
                   <a:srgbClr val="756F80"/>
                 </a:solidFill>
-                <a:latin typeface="Karla"/>
+                <a:latin typeface="Calibri"/>
               </a:rPr>
               <a:t>Ask at reception and they will find them for you.</a:t>
             </a:r>
@@ -9136,11 +9136,11 @@
               </a:spcAft>
             </a:pPr>
             <a:r>
-              <a:rPr sz="1350" b="1" i="0">
+              <a:rPr sz="1350" b="0" i="0">
                 <a:solidFill>
                   <a:srgbClr val="5B4F73"/>
                 </a:solidFill>
-                <a:latin typeface="Libre Caslon Display"/>
+                <a:latin typeface="Georgia"/>
               </a:rPr>
               <a:t>[ REPORTING ROUTE ]</a:t>
             </a:r>
@@ -9182,7 +9182,7 @@
                 <a:solidFill>
                   <a:srgbClr val="756F80"/>
                 </a:solidFill>
-                <a:latin typeface="Karla"/>
+                <a:latin typeface="Calibri"/>
               </a:rPr>
               <a:t>If you would rather not say it out loud.</a:t>
             </a:r>
@@ -9224,7 +9224,7 @@
                 <a:solidFill>
                   <a:srgbClr val="5B4F73"/>
                 </a:solidFill>
-                <a:latin typeface="Karla"/>
+                <a:latin typeface="Calibri"/>
               </a:rPr>
               <a:t>Nothing happens without talking to you first. You will not be marched into anything.</a:t>
             </a:r>
@@ -9290,7 +9290,7 @@
                 <a:solidFill>
                   <a:srgbClr val="A9A3B2"/>
                 </a:solidFill>
-                <a:latin typeface="Karla"/>
+                <a:latin typeface="Calibri"/>
               </a:rPr>
               <a:t>The Pastoral Guide</a:t>
             </a:r>
@@ -9332,7 +9332,7 @@
                 <a:solidFill>
                   <a:srgbClr val="A9A3B2"/>
                 </a:solidFill>
-                <a:latin typeface="Karla"/>
+                <a:latin typeface="Calibri"/>
               </a:rPr>
               <a:t>9 / 10</a:t>
             </a:r>

</xml_diff>

<commit_message>
Fix wording in Anti-Bullying Week deck, pack, page and cards
</commit_message>
<xml_diff>
--- a/assemblies-and-events/anti-bullying-week/downloads/Anti_Bullying_Week.pptx
+++ b/assemblies-and-events/anti-bullying-week/downloads/Anti_Bullying_Week.pptx
@@ -3566,7 +3566,7 @@
                 </a:solidFill>
                 <a:latin typeface="Georgia"/>
               </a:rPr>
-              <a:t>One week will not fix it.</a:t>
+              <a:t>This week is a good start.</a:t>
             </a:r>
           </a:p>
         </p:txBody>
@@ -3608,7 +3608,7 @@
                 </a:solidFill>
                 <a:latin typeface="Calibri"/>
               </a:rPr>
-              <a:t>Five days of noticing who is on their own, though, is a start. That part does not end on Friday.</a:t>
+              <a:t>Keep looking out for anybody who seems to be on their own, on Friday and after.</a:t>
             </a:r>
           </a:p>
         </p:txBody>
@@ -3862,7 +3862,7 @@
                 </a:solidFill>
                 <a:latin typeface="Georgia"/>
               </a:rPr>
-              <a:t>Most of it is not a fight.</a:t>
+              <a:t>Bullying is often much less obvious than a fight.</a:t>
             </a:r>
           </a:p>
           <a:p>
@@ -3881,7 +3881,7 @@
                 </a:solidFill>
                 <a:latin typeface="Georgia"/>
               </a:rPr>
-              <a:t>It is being left out, talked about, or made the joke.</a:t>
+              <a:t>It can be someone being left out, talked about, or laughed at.</a:t>
             </a:r>
           </a:p>
         </p:txBody>
@@ -3967,7 +3967,7 @@
                 </a:solidFill>
                 <a:latin typeface="Calibri"/>
               </a:rPr>
-              <a:t>Which is what makes it easy to miss, and easy to join in with without meaning to.</a:t>
+              <a:t>That is why it is easy to miss, and why people can join in without meaning to.</a:t>
             </a:r>
           </a:p>
         </p:txBody>
@@ -5263,7 +5263,7 @@
                 </a:solidFill>
                 <a:latin typeface="Calibri"/>
               </a:rPr>
-              <a:t>Each one takes about five minutes of your day, and none of them will get you into trouble.</a:t>
+              <a:t>Every one of them is open to everybody, and you can join in as much or as little as you like.</a:t>
             </a:r>
           </a:p>
         </p:txBody>
@@ -5649,7 +5649,7 @@
                 </a:solidFill>
                 <a:latin typeface="Calibri"/>
               </a:rPr>
-              <a:t>Wear odd socks with your uniform, all day. That is all there is to it. It takes two seconds to look different from everyone else, and nobody should get a hard time for it.</a:t>
+              <a:t>Please wear odd socks with your uniform all day. It is an easy way to join in, and everybody is welcome to take part, so nobody should get a hard time for it.</a:t>
             </a:r>
           </a:p>
         </p:txBody>
@@ -5826,7 +5826,7 @@
                 </a:solidFill>
                 <a:latin typeface="Calibri"/>
               </a:rPr>
-              <a:t>Nothing to bring</a:t>
+              <a:t>Just odd socks</a:t>
             </a:r>
           </a:p>
         </p:txBody>
@@ -6859,7 +6859,7 @@
                 </a:solidFill>
                 <a:latin typeface="Calibri"/>
               </a:rPr>
-              <a:t>Come and make a bracelet at lunch. You make two: one to keep, and one to give to somebody who would not be expecting it.</a:t>
+              <a:t>Come and make two bracelets at lunch. Keep one, and give the other to somebody who would not be expecting it, perhaps somebody you rarely talk to.</a:t>
             </a:r>
           </a:p>
         </p:txBody>
@@ -7078,7 +7078,7 @@
                 </a:solidFill>
                 <a:latin typeface="Calibri"/>
               </a:rPr>
-              <a:t>Thread and beads are provided. First come, first served.</a:t>
+              <a:t>Thread and beads are provided.</a:t>
             </a:r>
           </a:p>
         </p:txBody>
@@ -7464,7 +7464,7 @@
                 </a:solidFill>
                 <a:latin typeface="Calibri"/>
               </a:rPr>
-              <a:t>A group chat goes up on the wall. Read it, then put a sticky note where you think it went wrong, and what you would have said instead.</a:t>
+              <a:t>A group chat goes up on the wall. Read it, then stick a note on the message where you think it went wrong, and write what you would have said instead.</a:t>
             </a:r>
           </a:p>
         </p:txBody>
@@ -7683,7 +7683,7 @@
                 </a:solidFill>
                 <a:latin typeface="Calibri"/>
               </a:rPr>
-              <a:t>It is not a real chat, and it is not about anyone here.</a:t>
+              <a:t>This chat is made up, and it is not about anyone here.</a:t>
             </a:r>
           </a:p>
         </p:txBody>
@@ -8069,7 +8069,7 @@
                 </a:solidFill>
                 <a:latin typeface="Calibri"/>
               </a:rPr>
-              <a:t>Write something good about somebody in this school on a leaf, and hang it up. Not your best friend. Somebody who would not expect it from you.</a:t>
+              <a:t>Write something good about somebody in this school on a leaf, and hang it on the tree. Choose somebody who is not your best friend, ideally somebody who would not expect it from you.</a:t>
             </a:r>
           </a:p>
         </p:txBody>
@@ -8288,7 +8288,7 @@
                 </a:solidFill>
                 <a:latin typeface="Calibri"/>
               </a:rPr>
-              <a:t>You do not sign it. By the end of lunch the tree should be covered.</a:t>
+              <a:t>Please do not sign your leaf. We hope the tree will be full of kind words by the end of lunch.</a:t>
             </a:r>
           </a:p>
         </p:txBody>
@@ -8584,7 +8584,7 @@
                 </a:solidFill>
                 <a:latin typeface="Calibri"/>
               </a:rPr>
-              <a:t>Or you have watched it happen to someone else and said nothing. That counts too.</a:t>
+              <a:t>You can also tell someone if you have watched it happen to somebody else.</a:t>
             </a:r>
           </a:p>
         </p:txBody>
@@ -8784,7 +8784,7 @@
                 </a:solidFill>
                 <a:latin typeface="Calibri"/>
               </a:rPr>
-              <a:t>Any morning, before anything else starts.</a:t>
+              <a:t>Talk to them any morning, before the day starts.</a:t>
             </a:r>
           </a:p>
         </p:txBody>
@@ -9184,7 +9184,7 @@
                 </a:solidFill>
                 <a:latin typeface="Calibri"/>
               </a:rPr>
-              <a:t>If you would rather not say it out loud.</a:t>
+              <a:t>If you would rather not say it out loud, you can use this.</a:t>
             </a:r>
           </a:p>
         </p:txBody>
@@ -9226,7 +9226,7 @@
                 </a:solidFill>
                 <a:latin typeface="Calibri"/>
               </a:rPr>
-              <a:t>Nothing happens without talking to you first. You will not be marched into anything.</a:t>
+              <a:t>A member of staff will always talk to you before doing anything. If somebody could be in danger, they will need to tell the safeguarding lead, and they will explain that to you.</a:t>
             </a:r>
           </a:p>
         </p:txBody>

</xml_diff>